<commit_message>
docs: drop the course session number from the README, deck and video
</commit_message>
<xml_diff>
--- a/demo/presentation.pptx
+++ b/demo/presentation.pptx
@@ -128,38 +128,38 @@
   <p:extLst>
     <p:ext uri="{521415D9-36F7-43E2-AB2F-B90AF26B5E84}">
       <p14:sectionLst xmlns:p14="http://schemas.microsoft.com/office/powerpoint/2010/main">
-        <p14:section name="Introduction" id="{0707d6f6-b548-eee5-9f8c-eeb2661efd32}">
+        <p14:section name="Introduction" id="{7d5609b1-edb3-7515-5f72-ec9b953d03d1}">
           <p14:sldIdLst>
             <p14:sldId id="256"/>
             <p14:sldId id="257"/>
             <p14:sldId id="258"/>
           </p14:sldIdLst>
         </p14:section>
-        <p14:section name="Architecture" id="{f9dee0e6-374d-40c0-f7c7-1f6b6e23b252}">
+        <p14:section name="Architecture" id="{12b41014-0df6-ada8-ea8a-8be0731bcdfc}">
           <p14:sldIdLst>
             <p14:sldId id="259"/>
           </p14:sldIdLst>
         </p14:section>
-        <p14:section name="Application" id="{11d2f862-f637-303b-45bf-9c4b3a5b0d94}">
+        <p14:section name="Application" id="{b813faec-a9c4-7f37-22bd-161984754798}">
           <p14:sldIdLst>
             <p14:sldId id="260"/>
             <p14:sldId id="261"/>
             <p14:sldId id="262"/>
           </p14:sldIdLst>
         </p14:section>
-        <p14:section name="Build and test" id="{c4c67feb-42e7-1139-d0b9-33d2f10b1853}">
+        <p14:section name="Build and test" id="{638e2b44-2cd4-6f10-87a6-6f569063928c}">
           <p14:sldIdLst>
             <p14:sldId id="263"/>
             <p14:sldId id="264"/>
           </p14:sldIdLst>
         </p14:section>
-        <p14:section name="Delivery" id="{1a1b05da-138c-fd00-52ac-cedf30ddfbce}">
+        <p14:section name="Delivery" id="{b43536a7-a978-e3de-7be7-62791d34ef7f}">
           <p14:sldIdLst>
             <p14:sldId id="265"/>
             <p14:sldId id="266"/>
           </p14:sldIdLst>
         </p14:section>
-        <p14:section name="Infrastructure" id="{e3cbdd7e-91da-320a-d563-2b5b00555037}">
+        <p14:section name="Infrastructure" id="{6243e3c8-5451-5660-3b38-1ae883875834}">
           <p14:sldIdLst>
             <p14:sldId id="267"/>
             <p14:sldId id="268"/>
@@ -167,7 +167,7 @@
             <p14:sldId id="270"/>
           </p14:sldIdLst>
         </p14:section>
-        <p14:section name="Operate" id="{08ed023a-857b-60f5-37c0-7322eb85377d}">
+        <p14:section name="Operate" id="{1fedbb02-f1f9-ef7b-73b3-cac6341873cb}">
           <p14:sldIdLst>
             <p14:sldId id="271"/>
             <p14:sldId id="272"/>
@@ -175,7 +175,7 @@
             <p14:sldId id="274"/>
           </p14:sldIdLst>
         </p14:section>
-        <p14:section name="Wrap-up" id="{ef73840f-cd5b-b75f-e941-c70cde76d50f}">
+        <p14:section name="Wrap-up" id="{e6bad800-c83c-fbca-3166-b2e080396a90}">
           <p14:sldIdLst>
             <p14:sldId id="275"/>
             <p14:sldId id="276"/>
@@ -3453,7 +3453,7 @@
                   <a:schemeClr val="accent6"/>
                 </a:solidFill>
               </a:rPr>
-              <a:t>GearLoop  ·  Session 21 DevOps Capstone</a:t>
+              <a:t>GearLoop  ·  DevOps Capstone</a:t>
             </a:r>
             <a:endParaRPr lang="en-US" sz="1000" dirty="0"/>
           </a:p>
@@ -4008,7 +4008,7 @@
                   <a:schemeClr val="accent3"/>
                 </a:solidFill>
               </a:rPr>
-              <a:t>Session 21 · DevOps Final Capstone · Aastik Nayyar</a:t>
+              <a:t>DevOps Final Capstone · Aastik Nayyar</a:t>
             </a:r>
             <a:endParaRPr lang="en-US" sz="1500" dirty="0"/>
           </a:p>

</xml_diff>

<commit_message>
docs: recapture the pytest screenshot from the project's own virtualenv
</commit_message>
<xml_diff>
--- a/demo/presentation.pptx
+++ b/demo/presentation.pptx
@@ -128,38 +128,38 @@
   <p:extLst>
     <p:ext uri="{521415D9-36F7-43E2-AB2F-B90AF26B5E84}">
       <p14:sectionLst xmlns:p14="http://schemas.microsoft.com/office/powerpoint/2010/main">
-        <p14:section name="Introduction" id="{7d5609b1-edb3-7515-5f72-ec9b953d03d1}">
+        <p14:section name="Introduction" id="{9e964f48-35ff-3834-d816-f50b613444ab}">
           <p14:sldIdLst>
             <p14:sldId id="256"/>
             <p14:sldId id="257"/>
             <p14:sldId id="258"/>
           </p14:sldIdLst>
         </p14:section>
-        <p14:section name="Architecture" id="{12b41014-0df6-ada8-ea8a-8be0731bcdfc}">
+        <p14:section name="Architecture" id="{92e28bb2-8f39-64b2-5d5c-27616f5dabf5}">
           <p14:sldIdLst>
             <p14:sldId id="259"/>
           </p14:sldIdLst>
         </p14:section>
-        <p14:section name="Application" id="{b813faec-a9c4-7f37-22bd-161984754798}">
+        <p14:section name="Application" id="{54170dbb-12a6-c56e-3c95-ec18f46be117}">
           <p14:sldIdLst>
             <p14:sldId id="260"/>
             <p14:sldId id="261"/>
             <p14:sldId id="262"/>
           </p14:sldIdLst>
         </p14:section>
-        <p14:section name="Build and test" id="{638e2b44-2cd4-6f10-87a6-6f569063928c}">
+        <p14:section name="Build and test" id="{f04d2688-67a0-a338-d74b-e97d2b45af84}">
           <p14:sldIdLst>
             <p14:sldId id="263"/>
             <p14:sldId id="264"/>
           </p14:sldIdLst>
         </p14:section>
-        <p14:section name="Delivery" id="{b43536a7-a978-e3de-7be7-62791d34ef7f}">
+        <p14:section name="Delivery" id="{b21a4a02-caf1-adf8-ce22-1115e988aad1}">
           <p14:sldIdLst>
             <p14:sldId id="265"/>
             <p14:sldId id="266"/>
           </p14:sldIdLst>
         </p14:section>
-        <p14:section name="Infrastructure" id="{6243e3c8-5451-5660-3b38-1ae883875834}">
+        <p14:section name="Infrastructure" id="{b9d5fd35-b0a4-5ed3-4090-68f3ba468fc2}">
           <p14:sldIdLst>
             <p14:sldId id="267"/>
             <p14:sldId id="268"/>
@@ -167,7 +167,7 @@
             <p14:sldId id="270"/>
           </p14:sldIdLst>
         </p14:section>
-        <p14:section name="Operate" id="{1fedbb02-f1f9-ef7b-73b3-cac6341873cb}">
+        <p14:section name="Operate" id="{525d7002-b300-60c4-0f3a-0a651b5869ec}">
           <p14:sldIdLst>
             <p14:sldId id="271"/>
             <p14:sldId id="272"/>
@@ -175,7 +175,7 @@
             <p14:sldId id="274"/>
           </p14:sldIdLst>
         </p14:section>
-        <p14:section name="Wrap-up" id="{e6bad800-c83c-fbca-3166-b2e080396a90}">
+        <p14:section name="Wrap-up" id="{a703b7d3-91a5-f18b-4c85-9753b6a57293}">
           <p14:sldIdLst>
             <p14:sldId id="275"/>
             <p14:sldId id="276"/>
@@ -19526,8 +19526,8 @@
         </p:blipFill>
         <p:spPr>
           <a:xfrm>
-            <a:off x="548640" y="1325880"/>
-            <a:ext cx="7223760" cy="4406494"/>
+            <a:off x="1065356" y="1325880"/>
+            <a:ext cx="6190327" cy="4892040"/>
           </a:xfrm>
           <a:prstGeom prst="rect">
             <a:avLst/>

</xml_diff>